<commit_message>
docs(ppt): add fade transitions and entrance fade animations to synopsis deck
</commit_message>
<xml_diff>
--- a/ppt/PROJECT SYNOPSIS PPT-FORMAT_TRIMMED_V3.pptx
+++ b/ppt/PROJECT SYNOPSIS PPT-FORMAT_TRIMMED_V3.pptx
@@ -2571,6 +2571,83 @@
   <p:clrMapOvr>
     <a:masterClrMapping/>
   </p:clrMapOvr>
+  <p:transition spd="med">
+    <p:fade throuBlk="1"/>
+  </p:transition>
+  <p:timing>
+    <p:tnLst>
+      <p:par>
+        <p:cTn id="1" dur="indefinite" restart="never" nodeType="tmrPar">
+          <p:childTnLst>
+            <p:seq concurrent="1" nextAc="seek">
+              <p:cTn id="2" dur="indefinite" nodeType="mainSeq">
+                <p:childTnLst>
+                  <p:par>
+                    <p:cTn id="3" nodeType="withEffect" fill="hold">
+                      <p:stCondLst>
+                        <p:cond delay="0"/>
+                      </p:stCondLst>
+                      <p:childTnLst>
+                        <p:animEffect transition="in" filter="fade">
+                          <p:cBhvr>
+                            <p:cTn id="4" dur="750" fill="hold">
+                              <p:tgtEl>
+                                <p:spTgt spid="2">
+                                  <p:txEl>
+                                    <p:pRg st="0" end="1"/>
+                                  </p:txEl>
+                                </p:spTgt>
+                              </p:tgtEl>
+                            </p:cTn>
+                            <p:tgtEl>
+                              <p:spTgt spid="2">
+                                <p:txEl>
+                                  <p:pRg st="0" end="1"/>
+                                </p:txEl>
+                              </p:spTgt>
+                            </p:tgtEl>
+                          </p:cBhvr>
+                        </p:animEffect>
+                      </p:childTnLst>
+                    </p:cTn>
+                  </p:par>
+                  <p:par>
+                    <p:cTn id="5" nodeType="withEffect" fill="hold">
+                      <p:stCondLst>
+                        <p:cond delay="500"/>
+                      </p:stCondLst>
+                      <p:childTnLst>
+                        <p:animEffect transition="in" filter="fade">
+                          <p:cBhvr>
+                            <p:cTn id="6" dur="750" fill="hold">
+                              <p:tgtEl>
+                                <p:spTgt spid="2">
+                                  <p:txEl>
+                                    <p:pRg st="2" end="6"/>
+                                  </p:txEl>
+                                </p:spTgt>
+                              </p:tgtEl>
+                            </p:cTn>
+                            <p:tgtEl>
+                              <p:spTgt spid="2">
+                                <p:txEl>
+                                  <p:pRg st="2" end="6"/>
+                                </p:txEl>
+                              </p:spTgt>
+                            </p:tgtEl>
+                          </p:cBhvr>
+                        </p:animEffect>
+                      </p:childTnLst>
+                    </p:cTn>
+                  </p:par>
+                </p:childTnLst>
+              </p:cTn>
+            </p:seq>
+          </p:childTnLst>
+        </p:cTn>
+      </p:par>
+    </p:tnLst>
+  </p:timing>
 </p:sld>
 </file>
 
@@ -2640,6 +2717,54 @@
   <p:clrMapOvr>
     <a:masterClrMapping/>
   </p:clrMapOvr>
+  <p:transition spd="med">
+    <p:fade throuBlk="1"/>
+  </p:transition>
+  <p:timing>
+    <p:tnLst>
+      <p:par>
+        <p:cTn id="1" dur="indefinite" restart="never" nodeType="tmrPar">
+          <p:childTnLst>
+            <p:seq concurrent="1" nextAc="seek">
+              <p:cTn id="2" dur="indefinite" nodeType="mainSeq">
+                <p:childTnLst>
+                  <p:par>
+                    <p:cTn id="3" nodeType="withEffect" fill="hold">
+                      <p:stCondLst>
+                        <p:cond delay="200"/>
+                      </p:stCondLst>
+                      <p:childTnLst>
+                        <p:animEffect transition="in" filter="fade">
+                          <p:cBhvr>
+                            <p:cTn id="4" dur="750" fill="hold">
+                              <p:tgtEl>
+                                <p:spTgt spid="2">
+                                  <p:txEl>
+                                    <p:pRg st="0" end="0"/>
+                                  </p:txEl>
+                                </p:spTgt>
+                              </p:tgtEl>
+                            </p:cTn>
+                            <p:tgtEl>
+                              <p:spTgt spid="2">
+                                <p:txEl>
+                                  <p:pRg st="0" end="0"/>
+                                </p:txEl>
+                              </p:spTgt>
+                            </p:tgtEl>
+                          </p:cBhvr>
+                        </p:animEffect>
+                      </p:childTnLst>
+                    </p:cTn>
+                  </p:par>
+                </p:childTnLst>
+              </p:cTn>
+            </p:seq>
+          </p:childTnLst>
+        </p:cTn>
+      </p:par>
+    </p:tnLst>
+  </p:timing>
 </p:sld>
 </file>
 
@@ -3108,6 +3233,170 @@
   <p:clrMapOvr>
     <a:masterClrMapping/>
   </p:clrMapOvr>
+  <p:transition spd="med">
+    <p:fade throuBlk="1"/>
+  </p:transition>
+  <p:timing>
+    <p:tnLst>
+      <p:par>
+        <p:cTn id="1" dur="indefinite" restart="never" nodeType="tmrPar">
+          <p:childTnLst>
+            <p:seq concurrent="1" nextAc="seek">
+              <p:cTn id="2" dur="indefinite" nodeType="mainSeq">
+                <p:childTnLst>
+                  <p:par>
+                    <p:cTn id="3" nodeType="clickEffect" fill="hold">
+                      <p:stCondLst>
+                        <p:cond delay="indefinite"/>
+                      </p:stCondLst>
+                      <p:childTnLst>
+                        <p:animEffect transition="in" filter="fade">
+                          <p:cBhvr>
+                            <p:cTn id="4" dur="500" fill="hold">
+                              <p:tgtEl>
+                                <p:spTgt spid="2">
+                                  <p:txEl>
+                                    <p:pRg st="4" end="4"/>
+                                  </p:txEl>
+                                </p:spTgt>
+                              </p:tgtEl>
+                            </p:cTn>
+                            <p:tgtEl>
+                              <p:spTgt spid="2">
+                                <p:txEl>
+                                  <p:pRg st="4" end="4"/>
+                                </p:txEl>
+                              </p:spTgt>
+                            </p:tgtEl>
+                          </p:cBhvr>
+                        </p:animEffect>
+                      </p:childTnLst>
+                    </p:cTn>
+                  </p:par>
+                  <p:par>
+                    <p:cTn id="5" nodeType="clickEffect" fill="hold">
+                      <p:stCondLst>
+                        <p:cond delay="indefinite"/>
+                      </p:stCondLst>
+                      <p:childTnLst>
+                        <p:animEffect transition="in" filter="fade">
+                          <p:cBhvr>
+                            <p:cTn id="6" dur="500" fill="hold">
+                              <p:tgtEl>
+                                <p:spTgt spid="2">
+                                  <p:txEl>
+                                    <p:pRg st="5" end="5"/>
+                                  </p:txEl>
+                                </p:spTgt>
+                              </p:tgtEl>
+                            </p:cTn>
+                            <p:tgtEl>
+                              <p:spTgt spid="2">
+                                <p:txEl>
+                                  <p:pRg st="5" end="5"/>
+                                </p:txEl>
+                              </p:spTgt>
+                            </p:tgtEl>
+                          </p:cBhvr>
+                        </p:animEffect>
+                      </p:childTnLst>
+                    </p:cTn>
+                  </p:par>
+                  <p:par>
+                    <p:cTn id="7" nodeType="clickEffect" fill="hold">
+                      <p:stCondLst>
+                        <p:cond delay="indefinite"/>
+                      </p:stCondLst>
+                      <p:childTnLst>
+                        <p:animEffect transition="in" filter="fade">
+                          <p:cBhvr>
+                            <p:cTn id="8" dur="500" fill="hold">
+                              <p:tgtEl>
+                                <p:spTgt spid="2">
+                                  <p:txEl>
+                                    <p:pRg st="6" end="6"/>
+                                  </p:txEl>
+                                </p:spTgt>
+                              </p:tgtEl>
+                            </p:cTn>
+                            <p:tgtEl>
+                              <p:spTgt spid="2">
+                                <p:txEl>
+                                  <p:pRg st="6" end="6"/>
+                                </p:txEl>
+                              </p:spTgt>
+                            </p:tgtEl>
+                          </p:cBhvr>
+                        </p:animEffect>
+                      </p:childTnLst>
+                    </p:cTn>
+                  </p:par>
+                  <p:par>
+                    <p:cTn id="9" nodeType="clickEffect" fill="hold">
+                      <p:stCondLst>
+                        <p:cond delay="indefinite"/>
+                      </p:stCondLst>
+                      <p:childTnLst>
+                        <p:animEffect transition="in" filter="fade">
+                          <p:cBhvr>
+                            <p:cTn id="10" dur="500" fill="hold">
+                              <p:tgtEl>
+                                <p:spTgt spid="2">
+                                  <p:txEl>
+                                    <p:pRg st="7" end="7"/>
+                                  </p:txEl>
+                                </p:spTgt>
+                              </p:tgtEl>
+                            </p:cTn>
+                            <p:tgtEl>
+                              <p:spTgt spid="2">
+                                <p:txEl>
+                                  <p:pRg st="7" end="7"/>
+                                </p:txEl>
+                              </p:spTgt>
+                            </p:tgtEl>
+                          </p:cBhvr>
+                        </p:animEffect>
+                      </p:childTnLst>
+                    </p:cTn>
+                  </p:par>
+                  <p:par>
+                    <p:cTn id="11" nodeType="clickEffect" fill="hold">
+                      <p:stCondLst>
+                        <p:cond delay="indefinite"/>
+                      </p:stCondLst>
+                      <p:childTnLst>
+                        <p:animEffect transition="in" filter="fade">
+                          <p:cBhvr>
+                            <p:cTn id="12" dur="500" fill="hold">
+                              <p:tgtEl>
+                                <p:spTgt spid="2">
+                                  <p:txEl>
+                                    <p:pRg st="8" end="8"/>
+                                  </p:txEl>
+                                </p:spTgt>
+                              </p:tgtEl>
+                            </p:cTn>
+                            <p:tgtEl>
+                              <p:spTgt spid="2">
+                                <p:txEl>
+                                  <p:pRg st="8" end="8"/>
+                                </p:txEl>
+                              </p:spTgt>
+                            </p:tgtEl>
+                          </p:cBhvr>
+                        </p:animEffect>
+                      </p:childTnLst>
+                    </p:cTn>
+                  </p:par>
+                </p:childTnLst>
+              </p:cTn>
+            </p:seq>
+          </p:childTnLst>
+        </p:cTn>
+      </p:par>
+    </p:tnLst>
+  </p:timing>
 </p:sld>
 </file>
 
@@ -3586,6 +3875,170 @@
   <p:clrMapOvr>
     <a:masterClrMapping/>
   </p:clrMapOvr>
+  <p:transition spd="med">
+    <p:fade throuBlk="1"/>
+  </p:transition>
+  <p:timing>
+    <p:tnLst>
+      <p:par>
+        <p:cTn id="1" dur="indefinite" restart="never" nodeType="tmrPar">
+          <p:childTnLst>
+            <p:seq concurrent="1" nextAc="seek">
+              <p:cTn id="2" dur="indefinite" nodeType="mainSeq">
+                <p:childTnLst>
+                  <p:par>
+                    <p:cTn id="3" nodeType="clickEffect" fill="hold">
+                      <p:stCondLst>
+                        <p:cond delay="indefinite"/>
+                      </p:stCondLst>
+                      <p:childTnLst>
+                        <p:animEffect transition="in" filter="fade">
+                          <p:cBhvr>
+                            <p:cTn id="4" dur="500" fill="hold">
+                              <p:tgtEl>
+                                <p:spTgt spid="2">
+                                  <p:txEl>
+                                    <p:pRg st="4" end="4"/>
+                                  </p:txEl>
+                                </p:spTgt>
+                              </p:tgtEl>
+                            </p:cTn>
+                            <p:tgtEl>
+                              <p:spTgt spid="2">
+                                <p:txEl>
+                                  <p:pRg st="4" end="4"/>
+                                </p:txEl>
+                              </p:spTgt>
+                            </p:tgtEl>
+                          </p:cBhvr>
+                        </p:animEffect>
+                      </p:childTnLst>
+                    </p:cTn>
+                  </p:par>
+                  <p:par>
+                    <p:cTn id="5" nodeType="clickEffect" fill="hold">
+                      <p:stCondLst>
+                        <p:cond delay="indefinite"/>
+                      </p:stCondLst>
+                      <p:childTnLst>
+                        <p:animEffect transition="in" filter="fade">
+                          <p:cBhvr>
+                            <p:cTn id="6" dur="500" fill="hold">
+                              <p:tgtEl>
+                                <p:spTgt spid="2">
+                                  <p:txEl>
+                                    <p:pRg st="5" end="5"/>
+                                  </p:txEl>
+                                </p:spTgt>
+                              </p:tgtEl>
+                            </p:cTn>
+                            <p:tgtEl>
+                              <p:spTgt spid="2">
+                                <p:txEl>
+                                  <p:pRg st="5" end="5"/>
+                                </p:txEl>
+                              </p:spTgt>
+                            </p:tgtEl>
+                          </p:cBhvr>
+                        </p:animEffect>
+                      </p:childTnLst>
+                    </p:cTn>
+                  </p:par>
+                  <p:par>
+                    <p:cTn id="7" nodeType="clickEffect" fill="hold">
+                      <p:stCondLst>
+                        <p:cond delay="indefinite"/>
+                      </p:stCondLst>
+                      <p:childTnLst>
+                        <p:animEffect transition="in" filter="fade">
+                          <p:cBhvr>
+                            <p:cTn id="8" dur="500" fill="hold">
+                              <p:tgtEl>
+                                <p:spTgt spid="2">
+                                  <p:txEl>
+                                    <p:pRg st="6" end="6"/>
+                                  </p:txEl>
+                                </p:spTgt>
+                              </p:tgtEl>
+                            </p:cTn>
+                            <p:tgtEl>
+                              <p:spTgt spid="2">
+                                <p:txEl>
+                                  <p:pRg st="6" end="6"/>
+                                </p:txEl>
+                              </p:spTgt>
+                            </p:tgtEl>
+                          </p:cBhvr>
+                        </p:animEffect>
+                      </p:childTnLst>
+                    </p:cTn>
+                  </p:par>
+                  <p:par>
+                    <p:cTn id="9" nodeType="clickEffect" fill="hold">
+                      <p:stCondLst>
+                        <p:cond delay="indefinite"/>
+                      </p:stCondLst>
+                      <p:childTnLst>
+                        <p:animEffect transition="in" filter="fade">
+                          <p:cBhvr>
+                            <p:cTn id="10" dur="500" fill="hold">
+                              <p:tgtEl>
+                                <p:spTgt spid="2">
+                                  <p:txEl>
+                                    <p:pRg st="7" end="7"/>
+                                  </p:txEl>
+                                </p:spTgt>
+                              </p:tgtEl>
+                            </p:cTn>
+                            <p:tgtEl>
+                              <p:spTgt spid="2">
+                                <p:txEl>
+                                  <p:pRg st="7" end="7"/>
+                                </p:txEl>
+                              </p:spTgt>
+                            </p:tgtEl>
+                          </p:cBhvr>
+                        </p:animEffect>
+                      </p:childTnLst>
+                    </p:cTn>
+                  </p:par>
+                  <p:par>
+                    <p:cTn id="11" nodeType="clickEffect" fill="hold">
+                      <p:stCondLst>
+                        <p:cond delay="indefinite"/>
+                      </p:stCondLst>
+                      <p:childTnLst>
+                        <p:animEffect transition="in" filter="fade">
+                          <p:cBhvr>
+                            <p:cTn id="12" dur="500" fill="hold">
+                              <p:tgtEl>
+                                <p:spTgt spid="2">
+                                  <p:txEl>
+                                    <p:pRg st="8" end="8"/>
+                                  </p:txEl>
+                                </p:spTgt>
+                              </p:tgtEl>
+                            </p:cTn>
+                            <p:tgtEl>
+                              <p:spTgt spid="2">
+                                <p:txEl>
+                                  <p:pRg st="8" end="8"/>
+                                </p:txEl>
+                              </p:spTgt>
+                            </p:tgtEl>
+                          </p:cBhvr>
+                        </p:animEffect>
+                      </p:childTnLst>
+                    </p:cTn>
+                  </p:par>
+                </p:childTnLst>
+              </p:cTn>
+            </p:seq>
+          </p:childTnLst>
+        </p:cTn>
+      </p:par>
+    </p:tnLst>
+  </p:timing>
 </p:sld>
 </file>
 
@@ -6826,6 +7279,46 @@
   <p:clrMapOvr>
     <a:masterClrMapping/>
   </p:clrMapOvr>
+  <p:transition spd="med">
+    <p:fade throuBlk="1"/>
+  </p:transition>
+  <p:timing>
+    <p:tnLst>
+      <p:par>
+        <p:cTn id="1" dur="indefinite" restart="never" nodeType="tmrPar">
+          <p:childTnLst>
+            <p:seq concurrent="1" nextAc="seek">
+              <p:cTn id="2" dur="indefinite" nodeType="mainSeq">
+                <p:childTnLst>
+                  <p:par>
+                    <p:cTn id="3" nodeType="clickEffect" fill="hold">
+                      <p:stCondLst>
+                        <p:cond delay="indefinite"/>
+                      </p:stCondLst>
+                      <p:childTnLst>
+                        <p:animEffect transition="in" filter="fade">
+                          <p:cBhvr>
+                            <p:cTn id="4" dur="750" fill="hold">
+                              <p:tgtEl>
+                                <p:spTgt spid="7"/>
+                              </p:tgtEl>
+                            </p:cTn>
+                            <p:tgtEl>
+                              <p:spTgt spid="7"/>
+                            </p:tgtEl>
+                          </p:cBhvr>
+                        </p:animEffect>
+                      </p:childTnLst>
+                    </p:cTn>
+                  </p:par>
+                </p:childTnLst>
+              </p:cTn>
+            </p:seq>
+          </p:childTnLst>
+        </p:cTn>
+      </p:par>
+    </p:tnLst>
+  </p:timing>
 </p:sld>
 </file>
 
@@ -7250,6 +7743,83 @@
   <p:clrMapOvr>
     <a:masterClrMapping/>
   </p:clrMapOvr>
+  <p:transition spd="med">
+    <p:fade throuBlk="1"/>
+  </p:transition>
+  <p:timing>
+    <p:tnLst>
+      <p:par>
+        <p:cTn id="1" dur="indefinite" restart="never" nodeType="tmrPar">
+          <p:childTnLst>
+            <p:seq concurrent="1" nextAc="seek">
+              <p:cTn id="2" dur="indefinite" nodeType="mainSeq">
+                <p:childTnLst>
+                  <p:par>
+                    <p:cTn id="3" nodeType="clickEffect" fill="hold">
+                      <p:stCondLst>
+                        <p:cond delay="indefinite"/>
+                      </p:stCondLst>
+                      <p:childTnLst>
+                        <p:animEffect transition="in" filter="fade">
+                          <p:cBhvr>
+                            <p:cTn id="4" dur="500" fill="hold">
+                              <p:tgtEl>
+                                <p:spTgt spid="2">
+                                  <p:txEl>
+                                    <p:pRg st="4" end="4"/>
+                                  </p:txEl>
+                                </p:spTgt>
+                              </p:tgtEl>
+                            </p:cTn>
+                            <p:tgtEl>
+                              <p:spTgt spid="2">
+                                <p:txEl>
+                                  <p:pRg st="4" end="4"/>
+                                </p:txEl>
+                              </p:spTgt>
+                            </p:tgtEl>
+                          </p:cBhvr>
+                        </p:animEffect>
+                      </p:childTnLst>
+                    </p:cTn>
+                  </p:par>
+                  <p:par>
+                    <p:cTn id="5" nodeType="clickEffect" fill="hold">
+                      <p:stCondLst>
+                        <p:cond delay="indefinite"/>
+                      </p:stCondLst>
+                      <p:childTnLst>
+                        <p:animEffect transition="in" filter="fade">
+                          <p:cBhvr>
+                            <p:cTn id="6" dur="500" fill="hold">
+                              <p:tgtEl>
+                                <p:spTgt spid="2">
+                                  <p:txEl>
+                                    <p:pRg st="5" end="5"/>
+                                  </p:txEl>
+                                </p:spTgt>
+                              </p:tgtEl>
+                            </p:cTn>
+                            <p:tgtEl>
+                              <p:spTgt spid="2">
+                                <p:txEl>
+                                  <p:pRg st="5" end="5"/>
+                                </p:txEl>
+                              </p:spTgt>
+                            </p:tgtEl>
+                          </p:cBhvr>
+                        </p:animEffect>
+                      </p:childTnLst>
+                    </p:cTn>
+                  </p:par>
+                </p:childTnLst>
+              </p:cTn>
+            </p:seq>
+          </p:childTnLst>
+        </p:cTn>
+      </p:par>
+    </p:tnLst>
+  </p:timing>
 </p:sld>
 </file>
 
@@ -7812,6 +8382,199 @@
   <p:clrMapOvr>
     <a:masterClrMapping/>
   </p:clrMapOvr>
+  <p:transition spd="med">
+    <p:fade throuBlk="1"/>
+  </p:transition>
+  <p:timing>
+    <p:tnLst>
+      <p:par>
+        <p:cTn id="1" dur="indefinite" restart="never" nodeType="tmrPar">
+          <p:childTnLst>
+            <p:seq concurrent="1" nextAc="seek">
+              <p:cTn id="2" dur="indefinite" nodeType="mainSeq">
+                <p:childTnLst>
+                  <p:par>
+                    <p:cTn id="3" nodeType="clickEffect" fill="hold">
+                      <p:stCondLst>
+                        <p:cond delay="indefinite"/>
+                      </p:stCondLst>
+                      <p:childTnLst>
+                        <p:animEffect transition="in" filter="fade">
+                          <p:cBhvr>
+                            <p:cTn id="4" dur="500" fill="hold">
+                              <p:tgtEl>
+                                <p:spTgt spid="2">
+                                  <p:txEl>
+                                    <p:pRg st="4" end="4"/>
+                                  </p:txEl>
+                                </p:spTgt>
+                              </p:tgtEl>
+                            </p:cTn>
+                            <p:tgtEl>
+                              <p:spTgt spid="2">
+                                <p:txEl>
+                                  <p:pRg st="4" end="4"/>
+                                </p:txEl>
+                              </p:spTgt>
+                            </p:tgtEl>
+                          </p:cBhvr>
+                        </p:animEffect>
+                      </p:childTnLst>
+                    </p:cTn>
+                  </p:par>
+                  <p:par>
+                    <p:cTn id="5" nodeType="clickEffect" fill="hold">
+                      <p:stCondLst>
+                        <p:cond delay="indefinite"/>
+                      </p:stCondLst>
+                      <p:childTnLst>
+                        <p:animEffect transition="in" filter="fade">
+                          <p:cBhvr>
+                            <p:cTn id="6" dur="500" fill="hold">
+                              <p:tgtEl>
+                                <p:spTgt spid="2">
+                                  <p:txEl>
+                                    <p:pRg st="5" end="5"/>
+                                  </p:txEl>
+                                </p:spTgt>
+                              </p:tgtEl>
+                            </p:cTn>
+                            <p:tgtEl>
+                              <p:spTgt spid="2">
+                                <p:txEl>
+                                  <p:pRg st="5" end="5"/>
+                                </p:txEl>
+                              </p:spTgt>
+                            </p:tgtEl>
+                          </p:cBhvr>
+                        </p:animEffect>
+                      </p:childTnLst>
+                    </p:cTn>
+                  </p:par>
+                  <p:par>
+                    <p:cTn id="7" nodeType="clickEffect" fill="hold">
+                      <p:stCondLst>
+                        <p:cond delay="indefinite"/>
+                      </p:stCondLst>
+                      <p:childTnLst>
+                        <p:animEffect transition="in" filter="fade">
+                          <p:cBhvr>
+                            <p:cTn id="8" dur="500" fill="hold">
+                              <p:tgtEl>
+                                <p:spTgt spid="2">
+                                  <p:txEl>
+                                    <p:pRg st="6" end="6"/>
+                                  </p:txEl>
+                                </p:spTgt>
+                              </p:tgtEl>
+                            </p:cTn>
+                            <p:tgtEl>
+                              <p:spTgt spid="2">
+                                <p:txEl>
+                                  <p:pRg st="6" end="6"/>
+                                </p:txEl>
+                              </p:spTgt>
+                            </p:tgtEl>
+                          </p:cBhvr>
+                        </p:animEffect>
+                      </p:childTnLst>
+                    </p:cTn>
+                  </p:par>
+                  <p:par>
+                    <p:cTn id="9" nodeType="clickEffect" fill="hold">
+                      <p:stCondLst>
+                        <p:cond delay="indefinite"/>
+                      </p:stCondLst>
+                      <p:childTnLst>
+                        <p:animEffect transition="in" filter="fade">
+                          <p:cBhvr>
+                            <p:cTn id="10" dur="500" fill="hold">
+                              <p:tgtEl>
+                                <p:spTgt spid="2">
+                                  <p:txEl>
+                                    <p:pRg st="7" end="7"/>
+                                  </p:txEl>
+                                </p:spTgt>
+                              </p:tgtEl>
+                            </p:cTn>
+                            <p:tgtEl>
+                              <p:spTgt spid="2">
+                                <p:txEl>
+                                  <p:pRg st="7" end="7"/>
+                                </p:txEl>
+                              </p:spTgt>
+                            </p:tgtEl>
+                          </p:cBhvr>
+                        </p:animEffect>
+                      </p:childTnLst>
+                    </p:cTn>
+                  </p:par>
+                  <p:par>
+                    <p:cTn id="11" nodeType="clickEffect" fill="hold">
+                      <p:stCondLst>
+                        <p:cond delay="indefinite"/>
+                      </p:stCondLst>
+                      <p:childTnLst>
+                        <p:animEffect transition="in" filter="fade">
+                          <p:cBhvr>
+                            <p:cTn id="12" dur="500" fill="hold">
+                              <p:tgtEl>
+                                <p:spTgt spid="2">
+                                  <p:txEl>
+                                    <p:pRg st="8" end="8"/>
+                                  </p:txEl>
+                                </p:spTgt>
+                              </p:tgtEl>
+                            </p:cTn>
+                            <p:tgtEl>
+                              <p:spTgt spid="2">
+                                <p:txEl>
+                                  <p:pRg st="8" end="8"/>
+                                </p:txEl>
+                              </p:spTgt>
+                            </p:tgtEl>
+                          </p:cBhvr>
+                        </p:animEffect>
+                      </p:childTnLst>
+                    </p:cTn>
+                  </p:par>
+                  <p:par>
+                    <p:cTn id="13" nodeType="clickEffect" fill="hold">
+                      <p:stCondLst>
+                        <p:cond delay="indefinite"/>
+                      </p:stCondLst>
+                      <p:childTnLst>
+                        <p:animEffect transition="in" filter="fade">
+                          <p:cBhvr>
+                            <p:cTn id="14" dur="500" fill="hold">
+                              <p:tgtEl>
+                                <p:spTgt spid="2">
+                                  <p:txEl>
+                                    <p:pRg st="9" end="9"/>
+                                  </p:txEl>
+                                </p:spTgt>
+                              </p:tgtEl>
+                            </p:cTn>
+                            <p:tgtEl>
+                              <p:spTgt spid="2">
+                                <p:txEl>
+                                  <p:pRg st="9" end="9"/>
+                                </p:txEl>
+                              </p:spTgt>
+                            </p:tgtEl>
+                          </p:cBhvr>
+                        </p:animEffect>
+                      </p:childTnLst>
+                    </p:cTn>
+                  </p:par>
+                </p:childTnLst>
+              </p:cTn>
+            </p:seq>
+          </p:childTnLst>
+        </p:cTn>
+      </p:par>
+    </p:tnLst>
+  </p:timing>
 </p:sld>
 </file>
 
@@ -8343,6 +9106,199 @@
   <p:clrMapOvr>
     <a:masterClrMapping/>
   </p:clrMapOvr>
+  <p:transition spd="med">
+    <p:fade throuBlk="1"/>
+  </p:transition>
+  <p:timing>
+    <p:tnLst>
+      <p:par>
+        <p:cTn id="1" dur="indefinite" restart="never" nodeType="tmrPar">
+          <p:childTnLst>
+            <p:seq concurrent="1" nextAc="seek">
+              <p:cTn id="2" dur="indefinite" nodeType="mainSeq">
+                <p:childTnLst>
+                  <p:par>
+                    <p:cTn id="3" nodeType="clickEffect" fill="hold">
+                      <p:stCondLst>
+                        <p:cond delay="indefinite"/>
+                      </p:stCondLst>
+                      <p:childTnLst>
+                        <p:animEffect transition="in" filter="fade">
+                          <p:cBhvr>
+                            <p:cTn id="4" dur="500" fill="hold">
+                              <p:tgtEl>
+                                <p:spTgt spid="2">
+                                  <p:txEl>
+                                    <p:pRg st="4" end="4"/>
+                                  </p:txEl>
+                                </p:spTgt>
+                              </p:tgtEl>
+                            </p:cTn>
+                            <p:tgtEl>
+                              <p:spTgt spid="2">
+                                <p:txEl>
+                                  <p:pRg st="4" end="4"/>
+                                </p:txEl>
+                              </p:spTgt>
+                            </p:tgtEl>
+                          </p:cBhvr>
+                        </p:animEffect>
+                      </p:childTnLst>
+                    </p:cTn>
+                  </p:par>
+                  <p:par>
+                    <p:cTn id="5" nodeType="clickEffect" fill="hold">
+                      <p:stCondLst>
+                        <p:cond delay="indefinite"/>
+                      </p:stCondLst>
+                      <p:childTnLst>
+                        <p:animEffect transition="in" filter="fade">
+                          <p:cBhvr>
+                            <p:cTn id="6" dur="500" fill="hold">
+                              <p:tgtEl>
+                                <p:spTgt spid="2">
+                                  <p:txEl>
+                                    <p:pRg st="5" end="5"/>
+                                  </p:txEl>
+                                </p:spTgt>
+                              </p:tgtEl>
+                            </p:cTn>
+                            <p:tgtEl>
+                              <p:spTgt spid="2">
+                                <p:txEl>
+                                  <p:pRg st="5" end="5"/>
+                                </p:txEl>
+                              </p:spTgt>
+                            </p:tgtEl>
+                          </p:cBhvr>
+                        </p:animEffect>
+                      </p:childTnLst>
+                    </p:cTn>
+                  </p:par>
+                  <p:par>
+                    <p:cTn id="7" nodeType="clickEffect" fill="hold">
+                      <p:stCondLst>
+                        <p:cond delay="indefinite"/>
+                      </p:stCondLst>
+                      <p:childTnLst>
+                        <p:animEffect transition="in" filter="fade">
+                          <p:cBhvr>
+                            <p:cTn id="8" dur="500" fill="hold">
+                              <p:tgtEl>
+                                <p:spTgt spid="2">
+                                  <p:txEl>
+                                    <p:pRg st="6" end="6"/>
+                                  </p:txEl>
+                                </p:spTgt>
+                              </p:tgtEl>
+                            </p:cTn>
+                            <p:tgtEl>
+                              <p:spTgt spid="2">
+                                <p:txEl>
+                                  <p:pRg st="6" end="6"/>
+                                </p:txEl>
+                              </p:spTgt>
+                            </p:tgtEl>
+                          </p:cBhvr>
+                        </p:animEffect>
+                      </p:childTnLst>
+                    </p:cTn>
+                  </p:par>
+                  <p:par>
+                    <p:cTn id="9" nodeType="clickEffect" fill="hold">
+                      <p:stCondLst>
+                        <p:cond delay="indefinite"/>
+                      </p:stCondLst>
+                      <p:childTnLst>
+                        <p:animEffect transition="in" filter="fade">
+                          <p:cBhvr>
+                            <p:cTn id="10" dur="500" fill="hold">
+                              <p:tgtEl>
+                                <p:spTgt spid="2">
+                                  <p:txEl>
+                                    <p:pRg st="7" end="7"/>
+                                  </p:txEl>
+                                </p:spTgt>
+                              </p:tgtEl>
+                            </p:cTn>
+                            <p:tgtEl>
+                              <p:spTgt spid="2">
+                                <p:txEl>
+                                  <p:pRg st="7" end="7"/>
+                                </p:txEl>
+                              </p:spTgt>
+                            </p:tgtEl>
+                          </p:cBhvr>
+                        </p:animEffect>
+                      </p:childTnLst>
+                    </p:cTn>
+                  </p:par>
+                  <p:par>
+                    <p:cTn id="11" nodeType="clickEffect" fill="hold">
+                      <p:stCondLst>
+                        <p:cond delay="indefinite"/>
+                      </p:stCondLst>
+                      <p:childTnLst>
+                        <p:animEffect transition="in" filter="fade">
+                          <p:cBhvr>
+                            <p:cTn id="12" dur="500" fill="hold">
+                              <p:tgtEl>
+                                <p:spTgt spid="2">
+                                  <p:txEl>
+                                    <p:pRg st="8" end="8"/>
+                                  </p:txEl>
+                                </p:spTgt>
+                              </p:tgtEl>
+                            </p:cTn>
+                            <p:tgtEl>
+                              <p:spTgt spid="2">
+                                <p:txEl>
+                                  <p:pRg st="8" end="8"/>
+                                </p:txEl>
+                              </p:spTgt>
+                            </p:tgtEl>
+                          </p:cBhvr>
+                        </p:animEffect>
+                      </p:childTnLst>
+                    </p:cTn>
+                  </p:par>
+                  <p:par>
+                    <p:cTn id="13" nodeType="clickEffect" fill="hold">
+                      <p:stCondLst>
+                        <p:cond delay="indefinite"/>
+                      </p:stCondLst>
+                      <p:childTnLst>
+                        <p:animEffect transition="in" filter="fade">
+                          <p:cBhvr>
+                            <p:cTn id="14" dur="500" fill="hold">
+                              <p:tgtEl>
+                                <p:spTgt spid="2">
+                                  <p:txEl>
+                                    <p:pRg st="9" end="9"/>
+                                  </p:txEl>
+                                </p:spTgt>
+                              </p:tgtEl>
+                            </p:cTn>
+                            <p:tgtEl>
+                              <p:spTgt spid="2">
+                                <p:txEl>
+                                  <p:pRg st="9" end="9"/>
+                                </p:txEl>
+                              </p:spTgt>
+                            </p:tgtEl>
+                          </p:cBhvr>
+                        </p:animEffect>
+                      </p:childTnLst>
+                    </p:cTn>
+                  </p:par>
+                </p:childTnLst>
+              </p:cTn>
+            </p:seq>
+          </p:childTnLst>
+        </p:cTn>
+      </p:par>
+    </p:tnLst>
+  </p:timing>
 </p:sld>
 </file>
 
@@ -8874,6 +9830,199 @@
   <p:clrMapOvr>
     <a:masterClrMapping/>
   </p:clrMapOvr>
+  <p:transition spd="med">
+    <p:fade throuBlk="1"/>
+  </p:transition>
+  <p:timing>
+    <p:tnLst>
+      <p:par>
+        <p:cTn id="1" dur="indefinite" restart="never" nodeType="tmrPar">
+          <p:childTnLst>
+            <p:seq concurrent="1" nextAc="seek">
+              <p:cTn id="2" dur="indefinite" nodeType="mainSeq">
+                <p:childTnLst>
+                  <p:par>
+                    <p:cTn id="3" nodeType="clickEffect" fill="hold">
+                      <p:stCondLst>
+                        <p:cond delay="indefinite"/>
+                      </p:stCondLst>
+                      <p:childTnLst>
+                        <p:animEffect transition="in" filter="fade">
+                          <p:cBhvr>
+                            <p:cTn id="4" dur="500" fill="hold">
+                              <p:tgtEl>
+                                <p:spTgt spid="2">
+                                  <p:txEl>
+                                    <p:pRg st="4" end="4"/>
+                                  </p:txEl>
+                                </p:spTgt>
+                              </p:tgtEl>
+                            </p:cTn>
+                            <p:tgtEl>
+                              <p:spTgt spid="2">
+                                <p:txEl>
+                                  <p:pRg st="4" end="4"/>
+                                </p:txEl>
+                              </p:spTgt>
+                            </p:tgtEl>
+                          </p:cBhvr>
+                        </p:animEffect>
+                      </p:childTnLst>
+                    </p:cTn>
+                  </p:par>
+                  <p:par>
+                    <p:cTn id="5" nodeType="clickEffect" fill="hold">
+                      <p:stCondLst>
+                        <p:cond delay="indefinite"/>
+                      </p:stCondLst>
+                      <p:childTnLst>
+                        <p:animEffect transition="in" filter="fade">
+                          <p:cBhvr>
+                            <p:cTn id="6" dur="500" fill="hold">
+                              <p:tgtEl>
+                                <p:spTgt spid="2">
+                                  <p:txEl>
+                                    <p:pRg st="5" end="5"/>
+                                  </p:txEl>
+                                </p:spTgt>
+                              </p:tgtEl>
+                            </p:cTn>
+                            <p:tgtEl>
+                              <p:spTgt spid="2">
+                                <p:txEl>
+                                  <p:pRg st="5" end="5"/>
+                                </p:txEl>
+                              </p:spTgt>
+                            </p:tgtEl>
+                          </p:cBhvr>
+                        </p:animEffect>
+                      </p:childTnLst>
+                    </p:cTn>
+                  </p:par>
+                  <p:par>
+                    <p:cTn id="7" nodeType="clickEffect" fill="hold">
+                      <p:stCondLst>
+                        <p:cond delay="indefinite"/>
+                      </p:stCondLst>
+                      <p:childTnLst>
+                        <p:animEffect transition="in" filter="fade">
+                          <p:cBhvr>
+                            <p:cTn id="8" dur="500" fill="hold">
+                              <p:tgtEl>
+                                <p:spTgt spid="2">
+                                  <p:txEl>
+                                    <p:pRg st="6" end="6"/>
+                                  </p:txEl>
+                                </p:spTgt>
+                              </p:tgtEl>
+                            </p:cTn>
+                            <p:tgtEl>
+                              <p:spTgt spid="2">
+                                <p:txEl>
+                                  <p:pRg st="6" end="6"/>
+                                </p:txEl>
+                              </p:spTgt>
+                            </p:tgtEl>
+                          </p:cBhvr>
+                        </p:animEffect>
+                      </p:childTnLst>
+                    </p:cTn>
+                  </p:par>
+                  <p:par>
+                    <p:cTn id="9" nodeType="clickEffect" fill="hold">
+                      <p:stCondLst>
+                        <p:cond delay="indefinite"/>
+                      </p:stCondLst>
+                      <p:childTnLst>
+                        <p:animEffect transition="in" filter="fade">
+                          <p:cBhvr>
+                            <p:cTn id="10" dur="500" fill="hold">
+                              <p:tgtEl>
+                                <p:spTgt spid="2">
+                                  <p:txEl>
+                                    <p:pRg st="7" end="7"/>
+                                  </p:txEl>
+                                </p:spTgt>
+                              </p:tgtEl>
+                            </p:cTn>
+                            <p:tgtEl>
+                              <p:spTgt spid="2">
+                                <p:txEl>
+                                  <p:pRg st="7" end="7"/>
+                                </p:txEl>
+                              </p:spTgt>
+                            </p:tgtEl>
+                          </p:cBhvr>
+                        </p:animEffect>
+                      </p:childTnLst>
+                    </p:cTn>
+                  </p:par>
+                  <p:par>
+                    <p:cTn id="11" nodeType="clickEffect" fill="hold">
+                      <p:stCondLst>
+                        <p:cond delay="indefinite"/>
+                      </p:stCondLst>
+                      <p:childTnLst>
+                        <p:animEffect transition="in" filter="fade">
+                          <p:cBhvr>
+                            <p:cTn id="12" dur="500" fill="hold">
+                              <p:tgtEl>
+                                <p:spTgt spid="2">
+                                  <p:txEl>
+                                    <p:pRg st="8" end="8"/>
+                                  </p:txEl>
+                                </p:spTgt>
+                              </p:tgtEl>
+                            </p:cTn>
+                            <p:tgtEl>
+                              <p:spTgt spid="2">
+                                <p:txEl>
+                                  <p:pRg st="8" end="8"/>
+                                </p:txEl>
+                              </p:spTgt>
+                            </p:tgtEl>
+                          </p:cBhvr>
+                        </p:animEffect>
+                      </p:childTnLst>
+                    </p:cTn>
+                  </p:par>
+                  <p:par>
+                    <p:cTn id="13" nodeType="clickEffect" fill="hold">
+                      <p:stCondLst>
+                        <p:cond delay="indefinite"/>
+                      </p:stCondLst>
+                      <p:childTnLst>
+                        <p:animEffect transition="in" filter="fade">
+                          <p:cBhvr>
+                            <p:cTn id="14" dur="500" fill="hold">
+                              <p:tgtEl>
+                                <p:spTgt spid="2">
+                                  <p:txEl>
+                                    <p:pRg st="9" end="9"/>
+                                  </p:txEl>
+                                </p:spTgt>
+                              </p:tgtEl>
+                            </p:cTn>
+                            <p:tgtEl>
+                              <p:spTgt spid="2">
+                                <p:txEl>
+                                  <p:pRg st="9" end="9"/>
+                                </p:txEl>
+                              </p:spTgt>
+                            </p:tgtEl>
+                          </p:cBhvr>
+                        </p:animEffect>
+                      </p:childTnLst>
+                    </p:cTn>
+                  </p:par>
+                </p:childTnLst>
+              </p:cTn>
+            </p:seq>
+          </p:childTnLst>
+        </p:cTn>
+      </p:par>
+    </p:tnLst>
+  </p:timing>
 </p:sld>
 </file>
 
@@ -9385,6 +10534,46 @@
   <p:clrMapOvr>
     <a:masterClrMapping/>
   </p:clrMapOvr>
+  <p:transition spd="med">
+    <p:fade throuBlk="1"/>
+  </p:transition>
+  <p:timing>
+    <p:tnLst>
+      <p:par>
+        <p:cTn id="1" dur="indefinite" restart="never" nodeType="tmrPar">
+          <p:childTnLst>
+            <p:seq concurrent="1" nextAc="seek">
+              <p:cTn id="2" dur="indefinite" nodeType="mainSeq">
+                <p:childTnLst>
+                  <p:par>
+                    <p:cTn id="3" nodeType="clickEffect" fill="hold">
+                      <p:stCondLst>
+                        <p:cond delay="indefinite"/>
+                      </p:stCondLst>
+                      <p:childTnLst>
+                        <p:animEffect transition="in" filter="fade">
+                          <p:cBhvr>
+                            <p:cTn id="4" dur="750" fill="hold">
+                              <p:tgtEl>
+                                <p:spTgt spid="3"/>
+                              </p:tgtEl>
+                            </p:cTn>
+                            <p:tgtEl>
+                              <p:spTgt spid="3"/>
+                            </p:tgtEl>
+                          </p:cBhvr>
+                        </p:animEffect>
+                      </p:childTnLst>
+                    </p:cTn>
+                  </p:par>
+                </p:childTnLst>
+              </p:cTn>
+            </p:seq>
+          </p:childTnLst>
+        </p:cTn>
+      </p:par>
+    </p:tnLst>
+  </p:timing>
 </p:sld>
 </file>
 

</xml_diff>